<commit_message>
Deck 2.0: custom AI-generated art + shareable PDF package
- 7 bespoke visuals via OpenRouter (gemini-3-pro-image): pose-skeleton
  title/close heroes, training-alone problem art, three persona
  portraits, phone-propped demo-setup shot
- Slide 7 layout rework (demo art + QR + URL), refreshed proof-strip
  numbers, scripts updated to match
- PDF exports for easy sharing: deck, 4/5-speaker scripts, demo
  runbook & Q&A (plus editable .docx sources); ignore pptx lock files

Co-Authored-By: Claude Fable 5 <noreply@anthropic.com>
</commit_message>
<xml_diff>
--- a/presentation/RepMint-MVP-Deck.pptx
+++ b/presentation/RepMint-MVP-Deck.pptx
@@ -1856,7 +1856,7 @@
       </p:grpSpPr>
       <p:pic>
         <p:nvPicPr>
-          <p:cNvPr id="2" name="Image 0" descr="/Users/yk/Desktop/RepMint AI Personal Trainer/public/images/athletes/focus.jpg">    </p:cNvPr>
+          <p:cNvPr id="2" name="Image 0" descr="/private/tmp/claude-501/-Users-yk-Desktop-RepMint-AI-Personal-Trainer/51de5783-e5e6-4399-95df-3838b89cb49e/scratchpad/deckart-jpg/title-hero.jpg">    </p:cNvPr>
           <p:cNvPicPr>
             <a:picLocks noChangeAspect="1"/>
           </p:cNvPicPr>
@@ -1893,7 +1893,7 @@
           </a:prstGeom>
           <a:solidFill>
             <a:srgbClr val="0A0D10">
-              <a:alpha val="55000"/>
+              <a:alpha val="22000"/>
             </a:srgbClr>
           </a:solidFill>
           <a:ln/>
@@ -3532,7 +3532,7 @@
       </p:grpSpPr>
       <p:pic>
         <p:nvPicPr>
-          <p:cNvPr id="2" name="Image 0" descr="/Users/yk/Desktop/RepMint AI Personal Trainer/public/images/athletes/pushup.jpg">    </p:cNvPr>
+          <p:cNvPr id="2" name="Image 0" descr="/private/tmp/claude-501/-Users-yk-Desktop-RepMint-AI-Personal-Trainer/51de5783-e5e6-4399-95df-3838b89cb49e/scratchpad/deckart-jpg/close-hero.jpg">    </p:cNvPr>
           <p:cNvPicPr>
             <a:picLocks noChangeAspect="1"/>
           </p:cNvPicPr>
@@ -3569,7 +3569,7 @@
           </a:prstGeom>
           <a:solidFill>
             <a:srgbClr val="0A0D10">
-              <a:alpha val="78000"/>
+              <a:alpha val="45000"/>
             </a:srgbClr>
           </a:solidFill>
           <a:ln/>
@@ -3874,7 +3874,7 @@
       </p:sp>
       <p:pic>
         <p:nvPicPr>
-          <p:cNvPr id="4" name="Image 0" descr="/Users/yk/Desktop/RepMint AI Personal Trainer/public/images/athletes/squat-rack.jpg">    </p:cNvPr>
+          <p:cNvPr id="4" name="Image 0" descr="/private/tmp/claude-501/-Users-yk-Desktop-RepMint-AI-Personal-Trainer/51de5783-e5e6-4399-95df-3838b89cb49e/scratchpad/deckart-jpg/problem-solo.jpg">    </p:cNvPr>
           <p:cNvPicPr>
             <a:picLocks noChangeAspect="1"/>
           </p:cNvPicPr>
@@ -3911,7 +3911,7 @@
           </a:prstGeom>
           <a:solidFill>
             <a:srgbClr val="0A0D10">
-              <a:alpha val="40000"/>
+              <a:alpha val="15000"/>
             </a:srgbClr>
           </a:solidFill>
           <a:ln/>
@@ -5134,7 +5134,7 @@
       </p:sp>
       <p:pic>
         <p:nvPicPr>
-          <p:cNvPr id="5" name="Image 0" descr="/Users/yk/Desktop/RepMint AI Personal Trainer/public/images/athletes/deadlift.jpg">    </p:cNvPr>
+          <p:cNvPr id="5" name="Image 0" descr="/private/tmp/claude-501/-Users-yk-Desktop-RepMint-AI-Personal-Trainer/51de5783-e5e6-4399-95df-3838b89cb49e/scratchpad/deckart-jpg/persona-mateo.jpg">    </p:cNvPr>
           <p:cNvPicPr>
             <a:picLocks noChangeAspect="1"/>
           </p:cNvPicPr>
@@ -5314,7 +5314,7 @@
       </p:sp>
       <p:pic>
         <p:nvPicPr>
-          <p:cNvPr id="10" name="Image 1" descr="/Users/yk/Desktop/RepMint AI Personal Trainer/public/images/athletes/home-training.jpg">    </p:cNvPr>
+          <p:cNvPr id="10" name="Image 1" descr="/private/tmp/claude-501/-Users-yk-Desktop-RepMint-AI-Personal-Trainer/51de5783-e5e6-4399-95df-3838b89cb49e/scratchpad/deckart-jpg/persona-priya.jpg">    </p:cNvPr>
           <p:cNvPicPr>
             <a:picLocks noChangeAspect="1"/>
           </p:cNvPicPr>
@@ -5494,7 +5494,7 @@
       </p:sp>
       <p:pic>
         <p:nvPicPr>
-          <p:cNvPr id="15" name="Image 2" descr="/Users/yk/Desktop/RepMint AI Personal Trainer/public/images/athletes/kettlebell.jpg">    </p:cNvPr>
+          <p:cNvPr id="15" name="Image 2" descr="/private/tmp/claude-501/-Users-yk-Desktop-RepMint-AI-Personal-Trainer/51de5783-e5e6-4399-95df-3838b89cb49e/scratchpad/deckart-jpg/persona-lukas.jpg">    </p:cNvPr>
           <p:cNvPicPr>
             <a:picLocks noChangeAspect="1"/>
           </p:cNvPicPr>
@@ -6252,7 +6252,7 @@
                 <a:ea typeface="Arial" pitchFamily="34" charset="-122"/>
                 <a:cs typeface="Arial" pitchFamily="34" charset="-120"/>
               </a:rPr>
-              <a:t>40+ production deployments · 11 database migrations · 6 edge functions · 130 static pages · live at repmint.vercel.app</a:t>
+              <a:t>45+ production deployments · 13 database migrations · 115 exercises with custom AI-illustrated muscle maps · live at repmint.vercel.app</a:t>
             </a:r>
             <a:endParaRPr lang="en-US" sz="1150" dirty="0"/>
           </a:p>
@@ -7804,7 +7804,7 @@
       </p:sp>
       <p:pic>
         <p:nvPicPr>
-          <p:cNvPr id="16" name="Image 0" descr="preencoded.png">    </p:cNvPr>
+          <p:cNvPr id="16" name="Image 0" descr="/private/tmp/claude-501/-Users-yk-Desktop-RepMint-AI-Personal-Trainer/51de5783-e5e6-4399-95df-3838b89cb49e/scratchpad/deckart-jpg/demo-setup.jpg">    </p:cNvPr>
           <p:cNvPicPr>
             <a:picLocks noChangeAspect="1"/>
           </p:cNvPicPr>
@@ -7812,14 +7812,37 @@
         </p:nvPicPr>
         <p:blipFill>
           <a:blip r:embed="rId1"/>
+          <a:srcRect l="0" r="0" t="0" b="0"/>
+          <a:stretch/>
+        </p:blipFill>
+        <p:spPr>
+          <a:xfrm>
+            <a:off x="5989320" y="1691640"/>
+            <a:ext cx="2514600" cy="1417320"/>
+          </a:xfrm>
+          <a:prstGeom prst="rect">
+            <a:avLst/>
+          </a:prstGeom>
+        </p:spPr>
+      </p:pic>
+      <p:pic>
+        <p:nvPicPr>
+          <p:cNvPr id="17" name="Image 1" descr="preencoded.png">    </p:cNvPr>
+          <p:cNvPicPr>
+            <a:picLocks noChangeAspect="1"/>
+          </p:cNvPicPr>
+          <p:nvPr/>
+        </p:nvPicPr>
+        <p:blipFill>
+          <a:blip r:embed="rId2"/>
           <a:stretch>
             <a:fillRect/>
           </a:stretch>
         </p:blipFill>
         <p:spPr>
           <a:xfrm>
-            <a:off x="6419088" y="1783080"/>
-            <a:ext cx="1645920" cy="1645920"/>
+            <a:off x="6144768" y="3218688"/>
+            <a:ext cx="914400" cy="914400"/>
           </a:xfrm>
           <a:prstGeom prst="rect">
             <a:avLst/>
@@ -7828,14 +7851,76 @@
       </p:pic>
       <p:sp>
         <p:nvSpPr>
-          <p:cNvPr id="17" name="Text 14"/>
-          <p:cNvSpPr/>
-          <p:nvPr/>
-        </p:nvSpPr>
-        <p:spPr>
-          <a:xfrm>
-            <a:off x="5989320" y="3566160"/>
-            <a:ext cx="2514600" cy="320040"/>
+          <p:cNvPr id="18" name="Text 14"/>
+          <p:cNvSpPr/>
+          <p:nvPr/>
+        </p:nvSpPr>
+        <p:spPr>
+          <a:xfrm>
+            <a:off x="7150608" y="3291840"/>
+            <a:ext cx="1417320" cy="777240"/>
+          </a:xfrm>
+          <a:prstGeom prst="rect">
+            <a:avLst/>
+          </a:prstGeom>
+          <a:noFill/>
+          <a:ln/>
+        </p:spPr>
+        <p:txBody>
+          <a:bodyPr wrap="square" lIns="0" tIns="0" rIns="0" bIns="0" rtlCol="0" anchor="ctr"/>
+          <a:lstStyle/>
+          <a:p>
+            <a:pPr indent="0" marL="0">
+              <a:lnSpc>
+                <a:spcPts val="1300"/>
+              </a:lnSpc>
+              <a:buNone/>
+            </a:pPr>
+            <a:r>
+              <a:rPr lang="en-US" sz="950" dirty="0">
+                <a:solidFill>
+                  <a:srgbClr val="97A29D"/>
+                </a:solidFill>
+                <a:latin typeface="Arial" pitchFamily="34" charset="0"/>
+                <a:ea typeface="Arial" pitchFamily="34" charset="-122"/>
+                <a:cs typeface="Arial" pitchFamily="34" charset="-120"/>
+              </a:rPr>
+              <a:t>Deployed &amp; open —</a:t>
+            </a:r>
+            <a:endParaRPr lang="en-US" sz="950" dirty="0"/>
+          </a:p>
+          <a:p>
+            <a:pPr indent="0" marL="0">
+              <a:lnSpc>
+                <a:spcPts val="1300"/>
+              </a:lnSpc>
+              <a:buNone/>
+            </a:pPr>
+            <a:r>
+              <a:rPr lang="en-US" sz="950" dirty="0">
+                <a:solidFill>
+                  <a:srgbClr val="97A29D"/>
+                </a:solidFill>
+                <a:latin typeface="Arial" pitchFamily="34" charset="0"/>
+                <a:ea typeface="Arial" pitchFamily="34" charset="-122"/>
+                <a:cs typeface="Arial" pitchFamily="34" charset="-120"/>
+              </a:rPr>
+              <a:t>try it during Q&amp;A</a:t>
+            </a:r>
+            <a:endParaRPr lang="en-US" sz="950" dirty="0"/>
+          </a:p>
+        </p:txBody>
+      </p:sp>
+      <p:sp>
+        <p:nvSpPr>
+          <p:cNvPr id="19" name="Text 15"/>
+          <p:cNvSpPr/>
+          <p:nvPr/>
+        </p:nvSpPr>
+        <p:spPr>
+          <a:xfrm>
+            <a:off x="5989320" y="4224528"/>
+            <a:ext cx="2514600" cy="292608"/>
           </a:xfrm>
           <a:prstGeom prst="rect">
             <a:avLst/>
@@ -7851,7 +7936,7 @@
               <a:buNone/>
             </a:pPr>
             <a:r>
-              <a:rPr lang="en-US" sz="1300" b="1" dirty="0">
+              <a:rPr lang="en-US" sz="1150" b="1" dirty="0">
                 <a:solidFill>
                   <a:srgbClr val="B7FF3C"/>
                 </a:solidFill>
@@ -7861,55 +7946,13 @@
               </a:rPr>
               <a:t>repmint.vercel.app</a:t>
             </a:r>
-            <a:endParaRPr lang="en-US" sz="1300" dirty="0"/>
-          </a:p>
-        </p:txBody>
-      </p:sp>
-      <p:sp>
-        <p:nvSpPr>
-          <p:cNvPr id="18" name="Text 15"/>
-          <p:cNvSpPr/>
-          <p:nvPr/>
-        </p:nvSpPr>
-        <p:spPr>
-          <a:xfrm>
-            <a:off x="5989320" y="3913632"/>
-            <a:ext cx="2514600" cy="502920"/>
-          </a:xfrm>
-          <a:prstGeom prst="rect">
-            <a:avLst/>
-          </a:prstGeom>
-          <a:noFill/>
-          <a:ln/>
-        </p:spPr>
-        <p:txBody>
-          <a:bodyPr wrap="square" lIns="0" tIns="0" rIns="0" bIns="0" rtlCol="0" anchor="ctr"/>
-          <a:lstStyle/>
-          <a:p>
-            <a:pPr algn="ctr" indent="0" marL="0">
-              <a:lnSpc>
-                <a:spcPts val="1300"/>
-              </a:lnSpc>
-              <a:buNone/>
-            </a:pPr>
-            <a:r>
-              <a:rPr lang="en-US" sz="1000" dirty="0">
-                <a:solidFill>
-                  <a:srgbClr val="97A29D"/>
-                </a:solidFill>
-                <a:latin typeface="Arial" pitchFamily="34" charset="0"/>
-                <a:ea typeface="Arial" pitchFamily="34" charset="-122"/>
-                <a:cs typeface="Arial" pitchFamily="34" charset="-120"/>
-              </a:rPr>
-              <a:t>Deployed &amp; open — try it during Q&amp;A</a:t>
-            </a:r>
-            <a:endParaRPr lang="en-US" sz="1000" dirty="0"/>
-          </a:p>
-        </p:txBody>
-      </p:sp>
-      <p:sp>
-        <p:nvSpPr>
-          <p:cNvPr id="19" name="Text 16"/>
+            <a:endParaRPr lang="en-US" sz="1150" dirty="0"/>
+          </a:p>
+        </p:txBody>
+      </p:sp>
+      <p:sp>
+        <p:nvSpPr>
+          <p:cNvPr id="20" name="Text 16"/>
           <p:cNvSpPr/>
           <p:nvPr/>
         </p:nvSpPr>
@@ -7948,7 +7991,7 @@
       </p:sp>
       <p:sp>
         <p:nvSpPr>
-          <p:cNvPr id="20" name="Text 17"/>
+          <p:cNvPr id="21" name="Text 17"/>
           <p:cNvSpPr/>
           <p:nvPr/>
         </p:nvSpPr>
@@ -9468,7 +9511,7 @@
                 <a:ea typeface="Arial" pitchFamily="34" charset="-122"/>
                 <a:cs typeface="Arial" pitchFamily="34" charset="-120"/>
               </a:rPr>
-              <a:t>6 edge functions: ai-coach, generate-plan, tts, realtime-token…</a:t>
+              <a:t>Edge functions: ai-coach, generate-plan, tts, realtime-token…</a:t>
             </a:r>
             <a:endParaRPr lang="en-US" sz="900" dirty="0"/>
           </a:p>

</xml_diff>